<commit_message>
Use Calibri and Cambria in the decks and check that all text fits
Replace Arial and the Rockwell fonts with Office's Calibri (text) and
Cambria Bold (titles in the PZ and Mixed versions; Calibri Bold in the
Marketing one). Content titles are now in title case at 36 pt, so they
sit well inside the frames and cards. The key and the observations are
a little larger, and the observations are centred in their box.

check_fit.py wraps every paragraph word by word, measured with fonts as
wide as Calibri and Cambria, and fails the build if any text box, title
or table cell is too small for its text. build.sh runs it on all three
decks.

Co-Authored-By: Claude Opus 5.5 <noreply@anthropic.com>
Claude-Session: https://claude.ai/code/session_01WToQxHdrdWhM7bKqXvUa59
</commit_message>
<xml_diff>
--- a/assignment/Relative_Interest_Pie_Chart_Marketing.pptx
+++ b/assignment/Relative_Interest_Pie_Chart_Marketing.pptx
@@ -128,7 +128,7 @@
                 <a:solidFill>
                   <a:srgbClr val="000000"/>
                 </a:solidFill>
-                <a:latin typeface="Arial"/>
+                <a:latin typeface="Calibri"/>
               </a:rPr>
               <a:t>Share of Total Interest</a:t>
             </a:r>
@@ -290,7 +290,7 @@
                   <a:solidFill>
                     <a:srgbClr val="000000"/>
                   </a:solidFill>
-                  <a:latin typeface="Arial"/>
+                  <a:latin typeface="Calibri"/>
                 </a:defRPr>
               </a:pPr>
             </a:p>
@@ -317,7 +317,7 @@
           <a:solidFill>
             <a:srgbClr val="000000"/>
           </a:solidFill>
-          <a:latin typeface="Arial"/>
+          <a:latin typeface="Calibri"/>
         </a:defRPr>
       </a:pPr>
       <a:endParaRPr lang="en-US"/>
@@ -3948,11 +3948,11 @@
           <a:p>
             <a:pPr algn="ctr"/>
             <a:r>
-              <a:rPr sz="4400" b="1">
+              <a:rPr sz="4800" b="1">
                 <a:solidFill>
                   <a:srgbClr val="1F3864"/>
                 </a:solidFill>
-                <a:latin typeface="Arial"/>
+                <a:latin typeface="Calibri"/>
               </a:rPr>
               <a:t>Relative Interest</a:t>
             </a:r>
@@ -3989,7 +3989,7 @@
                 <a:solidFill>
                   <a:srgbClr val="000000"/>
                 </a:solidFill>
-                <a:latin typeface="Arial"/>
+                <a:latin typeface="Calibri"/>
               </a:rPr>
               <a:t>Digital Skills Programmes on Google Trends</a:t>
             </a:r>
@@ -4005,7 +4005,7 @@
                 <a:solidFill>
                   <a:srgbClr val="000000"/>
                 </a:solidFill>
-                <a:latin typeface="Arial"/>
+                <a:latin typeface="Calibri"/>
               </a:rPr>
               <a:t>Market Research Lab, Task 1  ·  Nigeria, past 12 months</a:t>
             </a:r>
@@ -4137,7 +4137,7 @@
                 <a:solidFill>
                   <a:srgbClr val="1F3864"/>
                 </a:solidFill>
-                <a:latin typeface="Arial"/>
+                <a:latin typeface="Calibri"/>
               </a:rPr>
               <a:t>Relative-Interest Observations</a:t>
             </a:r>
@@ -4181,7 +4181,7 @@
                           <a:solidFill>
                             <a:srgbClr val="FFFFFF"/>
                           </a:solidFill>
-                          <a:latin typeface="Arial"/>
+                          <a:latin typeface="Calibri"/>
                         </a:rPr>
                         <a:t>Programme</a:t>
                       </a:r>
@@ -4240,7 +4240,7 @@
                           <a:solidFill>
                             <a:srgbClr val="FFFFFF"/>
                           </a:solidFill>
-                          <a:latin typeface="Arial"/>
+                          <a:latin typeface="Calibri"/>
                         </a:rPr>
                         <a:t>Average score</a:t>
                       </a:r>
@@ -4299,7 +4299,7 @@
                           <a:solidFill>
                             <a:srgbClr val="FFFFFF"/>
                           </a:solidFill>
-                          <a:latin typeface="Arial"/>
+                          <a:latin typeface="Calibri"/>
                         </a:rPr>
                         <a:t>Rank</a:t>
                       </a:r>
@@ -4360,7 +4360,7 @@
                           <a:solidFill>
                             <a:srgbClr val="000000"/>
                           </a:solidFill>
-                          <a:latin typeface="Arial"/>
+                          <a:latin typeface="Calibri"/>
                         </a:rPr>
                         <a:t>Cybersecurity</a:t>
                       </a:r>
@@ -4417,7 +4417,7 @@
                           <a:solidFill>
                             <a:srgbClr val="000000"/>
                           </a:solidFill>
-                          <a:latin typeface="Arial"/>
+                          <a:latin typeface="Calibri"/>
                         </a:rPr>
                         <a:t>43</a:t>
                       </a:r>
@@ -4474,7 +4474,7 @@
                           <a:solidFill>
                             <a:srgbClr val="000000"/>
                           </a:solidFill>
-                          <a:latin typeface="Arial"/>
+                          <a:latin typeface="Calibri"/>
                         </a:rPr>
                         <a:t>1</a:t>
                       </a:r>
@@ -4533,7 +4533,7 @@
                           <a:solidFill>
                             <a:srgbClr val="000000"/>
                           </a:solidFill>
-                          <a:latin typeface="Arial"/>
+                          <a:latin typeface="Calibri"/>
                         </a:rPr>
                         <a:t>Digital Marketing</a:t>
                       </a:r>
@@ -4592,7 +4592,7 @@
                           <a:solidFill>
                             <a:srgbClr val="000000"/>
                           </a:solidFill>
-                          <a:latin typeface="Arial"/>
+                          <a:latin typeface="Calibri"/>
                         </a:rPr>
                         <a:t>33</a:t>
                       </a:r>
@@ -4651,7 +4651,7 @@
                           <a:solidFill>
                             <a:srgbClr val="000000"/>
                           </a:solidFill>
-                          <a:latin typeface="Arial"/>
+                          <a:latin typeface="Calibri"/>
                         </a:rPr>
                         <a:t>2</a:t>
                       </a:r>
@@ -4712,7 +4712,7 @@
                           <a:solidFill>
                             <a:srgbClr val="000000"/>
                           </a:solidFill>
-                          <a:latin typeface="Arial"/>
+                          <a:latin typeface="Calibri"/>
                         </a:rPr>
                         <a:t>Data Analytics</a:t>
                       </a:r>
@@ -4769,7 +4769,7 @@
                           <a:solidFill>
                             <a:srgbClr val="000000"/>
                           </a:solidFill>
-                          <a:latin typeface="Arial"/>
+                          <a:latin typeface="Calibri"/>
                         </a:rPr>
                         <a:t>18</a:t>
                       </a:r>
@@ -4826,7 +4826,7 @@
                           <a:solidFill>
                             <a:srgbClr val="000000"/>
                           </a:solidFill>
-                          <a:latin typeface="Arial"/>
+                          <a:latin typeface="Calibri"/>
                         </a:rPr>
                         <a:t>3</a:t>
                       </a:r>
@@ -4885,7 +4885,7 @@
                           <a:solidFill>
                             <a:srgbClr val="000000"/>
                           </a:solidFill>
-                          <a:latin typeface="Arial"/>
+                          <a:latin typeface="Calibri"/>
                         </a:rPr>
                         <a:t>Generative AI &amp; Prompt Engineering</a:t>
                       </a:r>
@@ -4944,7 +4944,7 @@
                           <a:solidFill>
                             <a:srgbClr val="000000"/>
                           </a:solidFill>
-                          <a:latin typeface="Arial"/>
+                          <a:latin typeface="Calibri"/>
                         </a:rPr>
                         <a:t>13</a:t>
                       </a:r>
@@ -5003,7 +5003,7 @@
                           <a:solidFill>
                             <a:srgbClr val="000000"/>
                           </a:solidFill>
-                          <a:latin typeface="Arial"/>
+                          <a:latin typeface="Calibri"/>
                         </a:rPr>
                         <a:t>4</a:t>
                       </a:r>
@@ -5064,7 +5064,7 @@
                           <a:solidFill>
                             <a:srgbClr val="000000"/>
                           </a:solidFill>
-                          <a:latin typeface="Arial"/>
+                          <a:latin typeface="Calibri"/>
                         </a:rPr>
                         <a:t>Web Development</a:t>
                       </a:r>
@@ -5121,7 +5121,7 @@
                           <a:solidFill>
                             <a:srgbClr val="000000"/>
                           </a:solidFill>
-                          <a:latin typeface="Arial"/>
+                          <a:latin typeface="Calibri"/>
                         </a:rPr>
                         <a:t>13</a:t>
                       </a:r>
@@ -5178,7 +5178,7 @@
                           <a:solidFill>
                             <a:srgbClr val="000000"/>
                           </a:solidFill>
-                          <a:latin typeface="Arial"/>
+                          <a:latin typeface="Calibri"/>
                         </a:rPr>
                         <a:t>4</a:t>
                       </a:r>
@@ -5292,7 +5292,7 @@
                 <a:solidFill>
                   <a:srgbClr val="404040"/>
                 </a:solidFill>
-                <a:latin typeface="Arial"/>
+                <a:latin typeface="Calibri"/>
               </a:rPr>
               <a:t>The average Google Trends score of each programme</a:t>
             </a:r>
@@ -5327,7 +5327,7 @@
                 <a:solidFill>
                   <a:srgbClr val="404040"/>
                 </a:solidFill>
-                <a:latin typeface="Arial"/>
+                <a:latin typeface="Calibri"/>
               </a:rPr>
               <a:t>Google Trends gives each programme a score from 0 to 100, where 100 means the highest interest.</a:t>
             </a:r>
@@ -5424,7 +5424,7 @@
                 <a:solidFill>
                   <a:srgbClr val="1F3864"/>
                 </a:solidFill>
-                <a:latin typeface="Arial"/>
+                <a:latin typeface="Calibri"/>
               </a:rPr>
               <a:t>Relative Interest by Programme</a:t>
             </a:r>
@@ -5514,7 +5514,7 @@
                 <a:solidFill>
                   <a:srgbClr val="404040"/>
                 </a:solidFill>
-                <a:latin typeface="Arial"/>
+                <a:latin typeface="Calibri"/>
               </a:rPr>
               <a:t>Each programme's share of the total interest</a:t>
             </a:r>
@@ -5589,22 +5589,22 @@
           <a:lstStyle/>
           <a:p>
             <a:r>
-              <a:rPr sz="1500" b="1">
+              <a:rPr sz="1600" b="1">
                 <a:solidFill>
                   <a:srgbClr val="000000"/>
                 </a:solidFill>
-                <a:latin typeface="Arial"/>
+                <a:latin typeface="Calibri"/>
               </a:rPr>
               <a:t>Cybersecurity</a:t>
             </a:r>
           </a:p>
           <a:p>
             <a:r>
-              <a:rPr sz="1400" b="0">
+              <a:rPr sz="1500" b="0">
                 <a:solidFill>
                   <a:srgbClr val="000000"/>
                 </a:solidFill>
-                <a:latin typeface="Arial"/>
+                <a:latin typeface="Calibri"/>
               </a:rPr>
               <a:t>Score 43  ·  36%</a:t>
             </a:r>
@@ -5679,22 +5679,22 @@
           <a:lstStyle/>
           <a:p>
             <a:r>
-              <a:rPr sz="1500" b="1">
+              <a:rPr sz="1600" b="1">
                 <a:solidFill>
                   <a:srgbClr val="000000"/>
                 </a:solidFill>
-                <a:latin typeface="Arial"/>
+                <a:latin typeface="Calibri"/>
               </a:rPr>
               <a:t>Digital Marketing</a:t>
             </a:r>
           </a:p>
           <a:p>
             <a:r>
-              <a:rPr sz="1400" b="0">
+              <a:rPr sz="1500" b="0">
                 <a:solidFill>
                   <a:srgbClr val="000000"/>
                 </a:solidFill>
-                <a:latin typeface="Arial"/>
+                <a:latin typeface="Calibri"/>
               </a:rPr>
               <a:t>Score 33  ·  28%</a:t>
             </a:r>
@@ -5769,22 +5769,22 @@
           <a:lstStyle/>
           <a:p>
             <a:r>
-              <a:rPr sz="1500" b="1">
+              <a:rPr sz="1600" b="1">
                 <a:solidFill>
                   <a:srgbClr val="000000"/>
                 </a:solidFill>
-                <a:latin typeface="Arial"/>
+                <a:latin typeface="Calibri"/>
               </a:rPr>
               <a:t>Data Analytics</a:t>
             </a:r>
           </a:p>
           <a:p>
             <a:r>
-              <a:rPr sz="1400" b="0">
+              <a:rPr sz="1500" b="0">
                 <a:solidFill>
                   <a:srgbClr val="000000"/>
                 </a:solidFill>
-                <a:latin typeface="Arial"/>
+                <a:latin typeface="Calibri"/>
               </a:rPr>
               <a:t>Score 18  ·  15%</a:t>
             </a:r>
@@ -5859,22 +5859,22 @@
           <a:lstStyle/>
           <a:p>
             <a:r>
-              <a:rPr sz="1500" b="1">
+              <a:rPr sz="1600" b="1">
                 <a:solidFill>
                   <a:srgbClr val="000000"/>
                 </a:solidFill>
-                <a:latin typeface="Arial"/>
+                <a:latin typeface="Calibri"/>
               </a:rPr>
               <a:t>Generative AI &amp; Prompt Engineering</a:t>
             </a:r>
           </a:p>
           <a:p>
             <a:r>
-              <a:rPr sz="1400" b="0">
+              <a:rPr sz="1500" b="0">
                 <a:solidFill>
                   <a:srgbClr val="000000"/>
                 </a:solidFill>
-                <a:latin typeface="Arial"/>
+                <a:latin typeface="Calibri"/>
               </a:rPr>
               <a:t>Score 13  ·  11%</a:t>
             </a:r>
@@ -5949,22 +5949,22 @@
           <a:lstStyle/>
           <a:p>
             <a:r>
-              <a:rPr sz="1500" b="1">
+              <a:rPr sz="1600" b="1">
                 <a:solidFill>
                   <a:srgbClr val="000000"/>
                 </a:solidFill>
-                <a:latin typeface="Arial"/>
+                <a:latin typeface="Calibri"/>
               </a:rPr>
               <a:t>Web Development</a:t>
             </a:r>
           </a:p>
           <a:p>
             <a:r>
-              <a:rPr sz="1400" b="0">
+              <a:rPr sz="1500" b="0">
                 <a:solidFill>
                   <a:srgbClr val="000000"/>
                 </a:solidFill>
-                <a:latin typeface="Arial"/>
+                <a:latin typeface="Calibri"/>
               </a:rPr>
               <a:t>Score 13  ·  11%</a:t>
             </a:r>
@@ -5999,7 +5999,7 @@
                 <a:solidFill>
                   <a:srgbClr val="404040"/>
                 </a:solidFill>
-                <a:latin typeface="Arial"/>
+                <a:latin typeface="Calibri"/>
               </a:rPr>
               <a:t>Source: Google Trends, Nigeria, past 12 months (28 September 2025 to 28 September 2026).</a:t>
             </a:r>
@@ -6096,7 +6096,7 @@
                 <a:solidFill>
                   <a:srgbClr val="1F3864"/>
                 </a:solidFill>
-                <a:latin typeface="Arial"/>
+                <a:latin typeface="Calibri"/>
               </a:rPr>
               <a:t>Observations</a:t>
             </a:r>
@@ -6163,7 +6163,7 @@
           </a:xfrm>
         </p:spPr>
         <p:txBody>
-          <a:bodyPr/>
+          <a:bodyPr anchor="ctr"/>
           <a:lstStyle/>
           <a:p>
             <a:pPr>
@@ -6172,20 +6172,20 @@
               </a:spcAft>
             </a:pPr>
             <a:r>
-              <a:rPr sz="2200" b="1">
+              <a:rPr sz="2400" b="1">
                 <a:solidFill>
                   <a:srgbClr val="000000"/>
                 </a:solidFill>
-                <a:latin typeface="Arial"/>
+                <a:latin typeface="Calibri"/>
               </a:rPr>
               <a:t>Cybersecurity</a:t>
             </a:r>
             <a:r>
-              <a:rPr sz="2200" b="0">
+              <a:rPr sz="2400" b="0">
                 <a:solidFill>
                   <a:srgbClr val="000000"/>
                 </a:solidFill>
-                <a:latin typeface="Arial"/>
+                <a:latin typeface="Calibri"/>
               </a:rPr>
               <a:t> had the highest interest, with 36% of the total.</a:t>
             </a:r>
@@ -6197,20 +6197,20 @@
               </a:spcAft>
             </a:pPr>
             <a:r>
-              <a:rPr sz="2200" b="1">
+              <a:rPr sz="2400" b="1">
                 <a:solidFill>
                   <a:srgbClr val="000000"/>
                 </a:solidFill>
-                <a:latin typeface="Arial"/>
+                <a:latin typeface="Calibri"/>
               </a:rPr>
               <a:t>Digital Marketing</a:t>
             </a:r>
             <a:r>
-              <a:rPr sz="2200" b="0">
+              <a:rPr sz="2400" b="0">
                 <a:solidFill>
                   <a:srgbClr val="000000"/>
                 </a:solidFill>
-                <a:latin typeface="Arial"/>
+                <a:latin typeface="Calibri"/>
               </a:rPr>
               <a:t> came second with 28%.</a:t>
             </a:r>
@@ -6222,20 +6222,20 @@
               </a:spcAft>
             </a:pPr>
             <a:r>
-              <a:rPr sz="2200" b="1">
+              <a:rPr sz="2400" b="1">
                 <a:solidFill>
                   <a:srgbClr val="000000"/>
                 </a:solidFill>
-                <a:latin typeface="Arial"/>
+                <a:latin typeface="Calibri"/>
               </a:rPr>
               <a:t>Data Analytics</a:t>
             </a:r>
             <a:r>
-              <a:rPr sz="2200" b="0">
+              <a:rPr sz="2400" b="0">
                 <a:solidFill>
                   <a:srgbClr val="000000"/>
                 </a:solidFill>
-                <a:latin typeface="Arial"/>
+                <a:latin typeface="Calibri"/>
               </a:rPr>
               <a:t> came third with 15%.</a:t>
             </a:r>
@@ -6247,38 +6247,38 @@
               </a:spcAft>
             </a:pPr>
             <a:r>
-              <a:rPr sz="2200" b="1">
+              <a:rPr sz="2400" b="1">
                 <a:solidFill>
                   <a:srgbClr val="000000"/>
                 </a:solidFill>
-                <a:latin typeface="Arial"/>
+                <a:latin typeface="Calibri"/>
               </a:rPr>
               <a:t>Generative AI &amp; Prompt Engineering</a:t>
             </a:r>
             <a:r>
-              <a:rPr sz="2200" b="0">
+              <a:rPr sz="2400" b="0">
                 <a:solidFill>
                   <a:srgbClr val="000000"/>
                 </a:solidFill>
-                <a:latin typeface="Arial"/>
+                <a:latin typeface="Calibri"/>
               </a:rPr>
               <a:t> and </a:t>
             </a:r>
             <a:r>
-              <a:rPr sz="2200" b="1">
+              <a:rPr sz="2400" b="1">
                 <a:solidFill>
                   <a:srgbClr val="000000"/>
                 </a:solidFill>
-                <a:latin typeface="Arial"/>
+                <a:latin typeface="Calibri"/>
               </a:rPr>
               <a:t>Web Development</a:t>
             </a:r>
             <a:r>
-              <a:rPr sz="2200" b="0">
+              <a:rPr sz="2400" b="0">
                 <a:solidFill>
                   <a:srgbClr val="000000"/>
                 </a:solidFill>
-                <a:latin typeface="Arial"/>
+                <a:latin typeface="Calibri"/>
               </a:rPr>
               <a:t> had the lowest interest, with 11% each.</a:t>
             </a:r>
@@ -6290,11 +6290,11 @@
               </a:spcAft>
             </a:pPr>
             <a:r>
-              <a:rPr sz="2200" b="0">
+              <a:rPr sz="2400" b="0">
                 <a:solidFill>
                   <a:srgbClr val="000000"/>
                 </a:solidFill>
-                <a:latin typeface="Arial"/>
+                <a:latin typeface="Calibri"/>
               </a:rPr>
               <a:t>This means Cybersecurity and Digital Marketing should be promoted first.</a:t>
             </a:r>
@@ -6364,7 +6364,7 @@
                 <a:solidFill>
                   <a:srgbClr val="404040"/>
                 </a:solidFill>
-                <a:latin typeface="Arial"/>
+                <a:latin typeface="Calibri"/>
               </a:rPr>
               <a:t>What the pie chart shows</a:t>
             </a:r>
@@ -6457,11 +6457,11 @@
           <a:p>
             <a:pPr algn="ctr"/>
             <a:r>
-              <a:rPr sz="4400" b="1">
+              <a:rPr sz="4800" b="1">
                 <a:solidFill>
                   <a:srgbClr val="1F3864"/>
                 </a:solidFill>
-                <a:latin typeface="Arial"/>
+                <a:latin typeface="Calibri"/>
               </a:rPr>
               <a:t>Thank You</a:t>
             </a:r>
@@ -6498,7 +6498,7 @@
                 <a:solidFill>
                   <a:srgbClr val="000000"/>
                 </a:solidFill>
-                <a:latin typeface="Arial"/>
+                <a:latin typeface="Calibri"/>
               </a:rPr>
               <a:t>Any questions?</a:t>
             </a:r>
@@ -6514,7 +6514,7 @@
                 <a:solidFill>
                   <a:srgbClr val="000000"/>
                 </a:solidFill>
-                <a:latin typeface="Arial"/>
+                <a:latin typeface="Calibri"/>
               </a:rPr>
               <a:t>Market Research Lab, Task 1</a:t>
             </a:r>
@@ -6610,12 +6610,12 @@
     </a:clrScheme>
     <a:fontScheme name="Office">
       <a:majorFont>
-        <a:latin typeface="Arial"/>
+        <a:latin typeface="Calibri"/>
         <a:ea typeface=""/>
         <a:cs typeface=""/>
       </a:majorFont>
       <a:minorFont>
-        <a:latin typeface="Arial"/>
+        <a:latin typeface="Calibri"/>
         <a:ea typeface=""/>
         <a:cs typeface=""/>
       </a:minorFont>
@@ -6811,12 +6811,12 @@
     </a:clrScheme>
     <a:fontScheme name="Office">
       <a:majorFont>
-        <a:latin typeface="Arial"/>
+        <a:latin typeface="Calibri"/>
         <a:ea typeface=""/>
         <a:cs typeface=""/>
       </a:majorFont>
       <a:minorFont>
-        <a:latin typeface="Arial"/>
+        <a:latin typeface="Calibri"/>
         <a:ea typeface=""/>
         <a:cs typeface=""/>
       </a:minorFont>

</xml_diff>